<commit_message>
Spec 002: NS, cohortes, robustez, distritos y figuras de apoyo
- Reproducción en Linux: datos en datasets/, entorno src/.venv con Python 3.12
  y fuente Liberation Sans en los entregables (D17).
- Spec 002 aprobada: secciones con NS alto y corrida sin ellas, volatilidad,
  PCA, comparación con Ward y mezcla gaussiana, cohortes y efecto del primer
  voto, trayectoria y composición por distrito federal (marcos 2021 y 2023)
  y corrida de apoyo por circunscripción (INE/CG130/2023).
- 19 figuras de estadísticas y algoritmos en entrega/estadisticas/.
- Documento técnico con NS, robustez, falacia ecológica, primer voto y
  distritos; sigue en 10 páginas.
- Tablas con orden fijo y 12 cifras significativas: dos corridas dan CSV
  idénticos. La corrida principal no cambia (k=5).
- 48 pruebas.

Co-Authored-By: Claude Opus 5.5 <noreply@anthropic.com>
</commit_message>
<xml_diff>
--- a/entrega/presentacion_ejecutiva.pptx
+++ b/entrega/presentacion_ejecutiva.pptx
@@ -3137,7 +3137,7 @@
                 <a:solidFill>
                   <a:srgbClr val="0B0B0B"/>
                 </a:solidFill>
-                <a:latin typeface="Arial"/>
+                <a:latin typeface="Liberation Sans"/>
               </a:rPr>
               <a:t>Perfiles ciudadanos de participación</a:t>
             </a:r>
@@ -3176,7 +3176,7 @@
                 <a:solidFill>
                   <a:srgbClr val="52514E"/>
                 </a:solidFill>
-                <a:latin typeface="Arial"/>
+                <a:latin typeface="Liberation Sans"/>
               </a:rPr>
               <a:t>Cinco maneras de participar en las elecciones federales, 2009 a 2024</a:t>
             </a:r>
@@ -3215,7 +3215,7 @@
                 <a:solidFill>
                   <a:srgbClr val="52514E"/>
                 </a:solidFill>
-                <a:latin typeface="Arial"/>
+                <a:latin typeface="Liberation Sans"/>
               </a:rPr>
               <a:t>Eje 1, Reto 1 · [NOMBRE DEL EQUIPO]</a:t>
             </a:r>
@@ -3231,7 +3231,7 @@
                 <a:solidFill>
                   <a:srgbClr val="52514E"/>
                 </a:solidFill>
-                <a:latin typeface="Arial"/>
+                <a:latin typeface="Liberation Sans"/>
               </a:rPr>
               <a:t>Borrador para revisión del equipo</a:t>
             </a:r>
@@ -3296,7 +3296,7 @@
                 <a:solidFill>
                   <a:srgbClr val="0B0B0B"/>
                 </a:solidFill>
-                <a:latin typeface="Arial"/>
+                <a:latin typeface="Liberation Sans"/>
               </a:rPr>
               <a:t>Limitaciones y próximos pasos</a:t>
             </a:r>
@@ -3335,7 +3335,7 @@
                 <a:solidFill>
                   <a:srgbClr val="0B0B0B"/>
                 </a:solidFill>
-                <a:latin typeface="Arial"/>
+                <a:latin typeface="Liberation Sans"/>
               </a:rPr>
               <a:t>Sin escolaridad en la fuente; se usa sexo y no género.</a:t>
             </a:r>
@@ -3351,7 +3351,7 @@
                 <a:solidFill>
                   <a:srgbClr val="0B0B0B"/>
                 </a:solidFill>
-                <a:latin typeface="Arial"/>
+                <a:latin typeface="Liberation Sans"/>
               </a:rPr>
               <a:t>Los perfiles describen franjas de edad, no a las mismas personas en el tiempo.</a:t>
             </a:r>
@@ -3367,7 +3367,7 @@
                 <a:solidFill>
                   <a:srgbClr val="0B0B0B"/>
                 </a:solidFill>
-                <a:latin typeface="Arial"/>
+                <a:latin typeface="Liberation Sans"/>
               </a:rPr>
               <a:t>Las causas (elecciones locales, movilidad laboral) son hipótesis por verificar.</a:t>
             </a:r>
@@ -3383,7 +3383,7 @@
                 <a:solidFill>
                   <a:srgbClr val="0B0B0B"/>
                 </a:solidFill>
-                <a:latin typeface="Arial"/>
+                <a:latin typeface="Liberation Sans"/>
               </a:rPr>
               <a:t>Pendiente: contrastar la participación nacional con la plataforma CCPC.</a:t>
             </a:r>
@@ -3399,7 +3399,7 @@
                 <a:solidFill>
                   <a:srgbClr val="0B0B0B"/>
                 </a:solidFill>
-                <a:latin typeface="Arial"/>
+                <a:latin typeface="Liberation Sans"/>
               </a:rPr>
               <a:t>Siguiente paso: piloto en dos o tres entidades con las estrategias 1 y 2.</a:t>
             </a:r>
@@ -3464,7 +3464,7 @@
                 <a:solidFill>
                   <a:srgbClr val="0B0B0B"/>
                 </a:solidFill>
-                <a:latin typeface="Arial"/>
+                <a:latin typeface="Liberation Sans"/>
               </a:rPr>
               <a:t>Seis elecciones, 32 entidades y una pregunta: ¿qué tipos de ciudadanía existen?</a:t>
             </a:r>
@@ -3503,7 +3503,7 @@
                 <a:solidFill>
                   <a:srgbClr val="0B0B0B"/>
                 </a:solidFill>
-                <a:latin typeface="Arial"/>
+                <a:latin typeface="Liberation Sans"/>
               </a:rPr>
               <a:t>Fuente: Conteos Censales de Participación Ciudadana (INE), 2009 a 2024.</a:t>
             </a:r>
@@ -3519,7 +3519,7 @@
                 <a:solidFill>
                   <a:srgbClr val="0B0B0B"/>
                 </a:solidFill>
-                <a:latin typeface="Arial"/>
+                <a:latin typeface="Liberation Sans"/>
               </a:rPr>
               <a:t>54,872,712 filas agregadas por sección, sexo y edad; sin datos personales.</a:t>
             </a:r>
@@ -3535,7 +3535,7 @@
                 <a:solidFill>
                   <a:srgbClr val="0B0B0B"/>
                 </a:solidFill>
-                <a:latin typeface="Arial"/>
+                <a:latin typeface="Liberation Sans"/>
               </a:rPr>
               <a:t>Lista nominal de 2024: 98,330,348 personas.</a:t>
             </a:r>
@@ -3551,7 +3551,7 @@
                 <a:solidFill>
                   <a:srgbClr val="0B0B0B"/>
                 </a:solidFill>
-                <a:latin typeface="Arial"/>
+                <a:latin typeface="Liberation Sans"/>
               </a:rPr>
               <a:t>Participación = SV / (SV + NV), sin las personas sin dato de voto.</a:t>
             </a:r>
@@ -3640,7 +3640,7 @@
                 <a:solidFill>
                   <a:srgbClr val="0B0B0B"/>
                 </a:solidFill>
-                <a:latin typeface="Arial"/>
+                <a:latin typeface="Liberation Sans"/>
               </a:rPr>
               <a:t>El método: celdas demográficas agrupadas por su comportamiento</a:t>
             </a:r>
@@ -3679,7 +3679,7 @@
                 <a:solidFill>
                   <a:srgbClr val="0B0B0B"/>
                 </a:solidFill>
-                <a:latin typeface="Arial"/>
+                <a:latin typeface="Liberation Sans"/>
               </a:rPr>
               <a:t>1. Unidad: celda = grupo de edad × sexo × tipo de sección × entidad.</a:t>
             </a:r>
@@ -3695,7 +3695,7 @@
                 <a:solidFill>
                   <a:srgbClr val="0B0B0B"/>
                 </a:solidFill>
-                <a:latin typeface="Arial"/>
+                <a:latin typeface="Liberation Sans"/>
               </a:rPr>
               <a:t>2. Medida: participación de la celda menos la de su entidad, en cada elección.</a:t>
             </a:r>
@@ -3711,7 +3711,7 @@
                 <a:solidFill>
                   <a:srgbClr val="0B0B0B"/>
                 </a:solidFill>
-                <a:latin typeface="Arial"/>
+                <a:latin typeface="Liberation Sans"/>
               </a:rPr>
               <a:t>3. Tres rasgos: nivel, brecha (presidencial menos intermedia) y tendencia.</a:t>
             </a:r>
@@ -3727,7 +3727,7 @@
                 <a:solidFill>
                   <a:srgbClr val="0B0B0B"/>
                 </a:solidFill>
-                <a:latin typeface="Arial"/>
+                <a:latin typeface="Liberation Sans"/>
               </a:rPr>
               <a:t>4. K-means ponderado por lista nominal, semilla fija, k entre 4 y 6.</a:t>
             </a:r>
@@ -3743,7 +3743,7 @@
                 <a:solidFill>
                   <a:srgbClr val="0B0B0B"/>
                 </a:solidFill>
-                <a:latin typeface="Arial"/>
+                <a:latin typeface="Liberation Sans"/>
               </a:rPr>
               <a:t>5. Validación: silhouette y estabilidad entre semillas y submuestras. Se eligió k = 5.</a:t>
             </a:r>
@@ -3759,7 +3759,7 @@
                 <a:solidFill>
                   <a:srgbClr val="0B0B0B"/>
                 </a:solidFill>
-                <a:latin typeface="Arial"/>
+                <a:latin typeface="Liberation Sans"/>
               </a:rPr>
               <a:t>6. Presencia territorial: composición de cada sección, clave (entidad, sección).</a:t>
             </a:r>
@@ -3824,7 +3824,7 @@
                 <a:solidFill>
                   <a:srgbClr val="0B0B0B"/>
                 </a:solidFill>
-                <a:latin typeface="Arial"/>
+                <a:latin typeface="Liberation Sans"/>
               </a:rPr>
               <a:t>Medir contra la propia entidad evita perfiles que son etiquetas de estado</a:t>
             </a:r>
@@ -3866,7 +3866,7 @@
                           <a:solidFill>
                             <a:srgbClr val="0B0B0B"/>
                           </a:solidFill>
-                          <a:latin typeface="Arial"/>
+                          <a:latin typeface="Liberation Sans"/>
                         </a:rPr>
                         <a:t>Referencia</a:t>
                       </a:r>
@@ -3888,7 +3888,7 @@
                           <a:solidFill>
                             <a:srgbClr val="0B0B0B"/>
                           </a:solidFill>
-                          <a:latin typeface="Arial"/>
+                          <a:latin typeface="Liberation Sans"/>
                         </a:rPr>
                         <a:t>Perfiles</a:t>
                       </a:r>
@@ -3910,7 +3910,7 @@
                           <a:solidFill>
                             <a:srgbClr val="0B0B0B"/>
                           </a:solidFill>
-                          <a:latin typeface="Arial"/>
+                          <a:latin typeface="Liberation Sans"/>
                         </a:rPr>
                         <a:t>Entidades con más de 80 % en un perfil</a:t>
                       </a:r>
@@ -3932,7 +3932,7 @@
                           <a:solidFill>
                             <a:srgbClr val="0B0B0B"/>
                           </a:solidFill>
-                          <a:latin typeface="Arial"/>
+                          <a:latin typeface="Liberation Sans"/>
                         </a:rPr>
                         <a:t>Varianza de la brecha explicada por la entidad</a:t>
                       </a:r>
@@ -3956,7 +3956,7 @@
                           <a:solidFill>
                             <a:srgbClr val="0B0B0B"/>
                           </a:solidFill>
-                          <a:latin typeface="Arial"/>
+                          <a:latin typeface="Liberation Sans"/>
                         </a:rPr>
                         <a:t>Nacional (prueba de sensibilidad)</a:t>
                       </a:r>
@@ -3978,7 +3978,7 @@
                           <a:solidFill>
                             <a:srgbClr val="0B0B0B"/>
                           </a:solidFill>
-                          <a:latin typeface="Arial"/>
+                          <a:latin typeface="Liberation Sans"/>
                         </a:rPr>
                         <a:t>4</a:t>
                       </a:r>
@@ -4000,7 +4000,7 @@
                           <a:solidFill>
                             <a:srgbClr val="0B0B0B"/>
                           </a:solidFill>
-                          <a:latin typeface="Arial"/>
+                          <a:latin typeface="Liberation Sans"/>
                         </a:rPr>
                         <a:t>10 de 32</a:t>
                       </a:r>
@@ -4022,7 +4022,7 @@
                           <a:solidFill>
                             <a:srgbClr val="0B0B0B"/>
                           </a:solidFill>
-                          <a:latin typeface="Arial"/>
+                          <a:latin typeface="Liberation Sans"/>
                         </a:rPr>
                         <a:t>74 %</a:t>
                       </a:r>
@@ -4046,7 +4046,7 @@
                           <a:solidFill>
                             <a:srgbClr val="0B0B0B"/>
                           </a:solidFill>
-                          <a:latin typeface="Arial"/>
+                          <a:latin typeface="Liberation Sans"/>
                         </a:rPr>
                         <a:t>Entidad (análisis principal)</a:t>
                       </a:r>
@@ -4068,7 +4068,7 @@
                           <a:solidFill>
                             <a:srgbClr val="0B0B0B"/>
                           </a:solidFill>
-                          <a:latin typeface="Arial"/>
+                          <a:latin typeface="Liberation Sans"/>
                         </a:rPr>
                         <a:t>5</a:t>
                       </a:r>
@@ -4090,7 +4090,7 @@
                           <a:solidFill>
                             <a:srgbClr val="0B0B0B"/>
                           </a:solidFill>
-                          <a:latin typeface="Arial"/>
+                          <a:latin typeface="Liberation Sans"/>
                         </a:rPr>
                         <a:t>0 de 32</a:t>
                       </a:r>
@@ -4112,7 +4112,7 @@
                           <a:solidFill>
                             <a:srgbClr val="0B0B0B"/>
                           </a:solidFill>
-                          <a:latin typeface="Arial"/>
+                          <a:latin typeface="Liberation Sans"/>
                         </a:rPr>
                         <a:t>0.1 %</a:t>
                       </a:r>
@@ -4161,7 +4161,7 @@
                 <a:solidFill>
                   <a:srgbClr val="0B0B0B"/>
                 </a:solidFill>
-                <a:latin typeface="Arial"/>
+                <a:latin typeface="Liberation Sans"/>
               </a:rPr>
               <a:t>Con la referencia nacional, algunas entidades quedaban casi enteras en un perfil.</a:t>
             </a:r>
@@ -4177,7 +4177,7 @@
                 <a:solidFill>
                   <a:srgbClr val="0B0B0B"/>
                 </a:solidFill>
-                <a:latin typeface="Arial"/>
+                <a:latin typeface="Liberation Sans"/>
               </a:rPr>
               <a:t>Una explicación posible es la concurrencia de elecciones locales; no se pudo verificar con estos datos.</a:t>
             </a:r>
@@ -4242,7 +4242,7 @@
                 <a:solidFill>
                   <a:srgbClr val="0B0B0B"/>
                 </a:solidFill>
-                <a:latin typeface="Arial"/>
+                <a:latin typeface="Liberation Sans"/>
               </a:rPr>
               <a:t>Cinco perfiles; los dos más jóvenes son la prioridad</a:t>
             </a:r>
@@ -4305,7 +4305,7 @@
                 <a:solidFill>
                   <a:srgbClr val="0B0B0B"/>
                 </a:solidFill>
-                <a:latin typeface="Arial"/>
+                <a:latin typeface="Liberation Sans"/>
               </a:rPr>
               <a:t>34 % de la lista tiene el perfil 1, el más numeroso.</a:t>
             </a:r>
@@ -4321,7 +4321,7 @@
                 <a:solidFill>
                   <a:srgbClr val="0B0B0B"/>
                 </a:solidFill>
-                <a:latin typeface="Arial"/>
+                <a:latin typeface="Liberation Sans"/>
               </a:rPr>
               <a:t>El perfil 2 pesa 9 % y es el que más cayó en presidenciales.</a:t>
             </a:r>
@@ -4337,7 +4337,7 @@
                 <a:solidFill>
                   <a:srgbClr val="0B0B0B"/>
                 </a:solidFill>
-                <a:latin typeface="Arial"/>
+                <a:latin typeface="Liberation Sans"/>
               </a:rPr>
               <a:t>Los perfiles 3, 4 y 5 son de mayor edad y participan más.</a:t>
             </a:r>
@@ -4402,7 +4402,7 @@
                 <a:solidFill>
                   <a:srgbClr val="0B0B0B"/>
                 </a:solidFill>
-                <a:latin typeface="Arial"/>
+                <a:latin typeface="Liberation Sans"/>
               </a:rPr>
               <a:t>Se distinguen por cuánto participan y cómo cambia entre tipos de elección</a:t>
             </a:r>
@@ -4465,7 +4465,7 @@
                 <a:solidFill>
                   <a:srgbClr val="0B0B0B"/>
                 </a:solidFill>
-                <a:latin typeface="Arial"/>
+                <a:latin typeface="Liberation Sans"/>
               </a:rPr>
               <a:t>Perfil 1: 16 puntos más en presidenciales que en intermedias.</a:t>
             </a:r>
@@ -4481,7 +4481,7 @@
                 <a:solidFill>
                   <a:srgbClr val="0B0B0B"/>
                 </a:solidFill>
-                <a:latin typeface="Arial"/>
+                <a:latin typeface="Liberation Sans"/>
               </a:rPr>
               <a:t>Perfil 2: de 54 % (2012) a 45 % (2024).</a:t>
             </a:r>
@@ -4497,7 +4497,7 @@
                 <a:solidFill>
                   <a:srgbClr val="0B0B0B"/>
                 </a:solidFill>
-                <a:latin typeface="Arial"/>
+                <a:latin typeface="Liberation Sans"/>
               </a:rPr>
               <a:t>Perfil 4: de 49 % (2009) a 71 % (2024).</a:t>
             </a:r>
@@ -4562,7 +4562,7 @@
                 <a:solidFill>
                   <a:srgbClr val="0B0B0B"/>
                 </a:solidFill>
-                <a:latin typeface="Arial"/>
+                <a:latin typeface="Liberation Sans"/>
               </a:rPr>
               <a:t>Prioridad alta: jóvenes con participación desigual o en caída</a:t>
             </a:r>
@@ -4601,7 +4601,7 @@
                 <a:solidFill>
                   <a:srgbClr val="0B0B0B"/>
                 </a:solidFill>
-                <a:latin typeface="Arial"/>
+                <a:latin typeface="Liberation Sans"/>
               </a:rPr>
               <a:t>1. Jóvenes urbanos de coyuntura</a:t>
             </a:r>
@@ -4617,7 +4617,7 @@
                 <a:solidFill>
                   <a:srgbClr val="0B0B0B"/>
                 </a:solidFill>
-                <a:latin typeface="Arial"/>
+                <a:latin typeface="Liberation Sans"/>
               </a:rPr>
               <a:t>34 % de la lista; mediana 25-29 años</a:t>
             </a:r>
@@ -4633,7 +4633,7 @@
                 <a:solidFill>
                   <a:srgbClr val="0B0B0B"/>
                 </a:solidFill>
-                <a:latin typeface="Arial"/>
+                <a:latin typeface="Liberation Sans"/>
               </a:rPr>
               <a:t>45 % mujeres; 95 % urbana</a:t>
             </a:r>
@@ -4649,7 +4649,7 @@
                 <a:solidFill>
                   <a:srgbClr val="0B0B0B"/>
                 </a:solidFill>
-                <a:latin typeface="Arial"/>
+                <a:latin typeface="Liberation Sans"/>
               </a:rPr>
               <a:t>Participación 2024: 51 %</a:t>
             </a:r>
@@ -4688,7 +4688,7 @@
                 <a:solidFill>
                   <a:srgbClr val="0B0B0B"/>
                 </a:solidFill>
-                <a:latin typeface="Arial"/>
+                <a:latin typeface="Liberation Sans"/>
               </a:rPr>
               <a:t>2. Jóvenes del campo en retirada</a:t>
             </a:r>
@@ -4704,7 +4704,7 @@
                 <a:solidFill>
                   <a:srgbClr val="0B0B0B"/>
                 </a:solidFill>
-                <a:latin typeface="Arial"/>
+                <a:latin typeface="Liberation Sans"/>
               </a:rPr>
               <a:t>9 % de la lista; mediana 25-29 años</a:t>
             </a:r>
@@ -4720,7 +4720,7 @@
                 <a:solidFill>
                   <a:srgbClr val="0B0B0B"/>
                 </a:solidFill>
-                <a:latin typeface="Arial"/>
+                <a:latin typeface="Liberation Sans"/>
               </a:rPr>
               <a:t>23 % mujeres; 2 % urbana</a:t>
             </a:r>
@@ -4736,7 +4736,7 @@
                 <a:solidFill>
                   <a:srgbClr val="0B0B0B"/>
                 </a:solidFill>
-                <a:latin typeface="Arial"/>
+                <a:latin typeface="Liberation Sans"/>
               </a:rPr>
               <a:t>Participación 2024: 45 %</a:t>
             </a:r>
@@ -4801,7 +4801,7 @@
                 <a:solidFill>
                   <a:srgbClr val="0B0B0B"/>
                 </a:solidFill>
-                <a:latin typeface="Arial"/>
+                <a:latin typeface="Liberation Sans"/>
               </a:rPr>
               <a:t>Prioridad media y mantener: adultez y vejez con participación alta</a:t>
             </a:r>
@@ -4840,7 +4840,7 @@
                 <a:solidFill>
                   <a:srgbClr val="0B0B0B"/>
                 </a:solidFill>
-                <a:latin typeface="Arial"/>
+                <a:latin typeface="Liberation Sans"/>
               </a:rPr>
               <a:t>3. Adultez urbana constante</a:t>
             </a:r>
@@ -4856,7 +4856,7 @@
                 <a:solidFill>
                   <a:srgbClr val="0B0B0B"/>
                 </a:solidFill>
-                <a:latin typeface="Arial"/>
+                <a:latin typeface="Liberation Sans"/>
               </a:rPr>
               <a:t>30 % de la lista; mediana 45-49 años</a:t>
             </a:r>
@@ -4872,7 +4872,7 @@
                 <a:solidFill>
                   <a:srgbClr val="0B0B0B"/>
                 </a:solidFill>
-                <a:latin typeface="Arial"/>
+                <a:latin typeface="Liberation Sans"/>
               </a:rPr>
               <a:t>62 % mujeres; 83 % urbana</a:t>
             </a:r>
@@ -4888,7 +4888,7 @@
                 <a:solidFill>
                   <a:srgbClr val="0B0B0B"/>
                 </a:solidFill>
-                <a:latin typeface="Arial"/>
+                <a:latin typeface="Liberation Sans"/>
               </a:rPr>
               <a:t>Participación 2024: 64 %</a:t>
             </a:r>
@@ -4927,7 +4927,7 @@
                 <a:solidFill>
                   <a:srgbClr val="0B0B0B"/>
                 </a:solidFill>
-                <a:latin typeface="Arial"/>
+                <a:latin typeface="Liberation Sans"/>
               </a:rPr>
               <a:t>4. Mayores en ascenso</a:t>
             </a:r>
@@ -4943,7 +4943,7 @@
                 <a:solidFill>
                   <a:srgbClr val="0B0B0B"/>
                 </a:solidFill>
-                <a:latin typeface="Arial"/>
+                <a:latin typeface="Liberation Sans"/>
               </a:rPr>
               <a:t>13 % de la lista; mediana 65-69 años</a:t>
             </a:r>
@@ -4959,7 +4959,7 @@
                 <a:solidFill>
                   <a:srgbClr val="0B0B0B"/>
                 </a:solidFill>
-                <a:latin typeface="Arial"/>
+                <a:latin typeface="Liberation Sans"/>
               </a:rPr>
               <a:t>68 % mujeres; 62 % urbana</a:t>
             </a:r>
@@ -4975,7 +4975,7 @@
                 <a:solidFill>
                   <a:srgbClr val="0B0B0B"/>
                 </a:solidFill>
-                <a:latin typeface="Arial"/>
+                <a:latin typeface="Liberation Sans"/>
               </a:rPr>
               <a:t>Participación 2024: 71 %</a:t>
             </a:r>
@@ -5014,7 +5014,7 @@
                 <a:solidFill>
                   <a:srgbClr val="0B0B0B"/>
                 </a:solidFill>
-                <a:latin typeface="Arial"/>
+                <a:latin typeface="Liberation Sans"/>
               </a:rPr>
               <a:t>5. Adultez rural de alta participación</a:t>
             </a:r>
@@ -5030,7 +5030,7 @@
                 <a:solidFill>
                   <a:srgbClr val="0B0B0B"/>
                 </a:solidFill>
-                <a:latin typeface="Arial"/>
+                <a:latin typeface="Liberation Sans"/>
               </a:rPr>
               <a:t>14 % de la lista; mediana 55-59 años</a:t>
             </a:r>
@@ -5046,7 +5046,7 @@
                 <a:solidFill>
                   <a:srgbClr val="0B0B0B"/>
                 </a:solidFill>
-                <a:latin typeface="Arial"/>
+                <a:latin typeface="Liberation Sans"/>
               </a:rPr>
               <a:t>54 % mujeres; 30 % urbana</a:t>
             </a:r>
@@ -5062,7 +5062,7 @@
                 <a:solidFill>
                   <a:srgbClr val="0B0B0B"/>
                 </a:solidFill>
-                <a:latin typeface="Arial"/>
+                <a:latin typeface="Liberation Sans"/>
               </a:rPr>
               <a:t>Participación 2024: 70 %</a:t>
             </a:r>
@@ -5127,7 +5127,7 @@
                 <a:solidFill>
                   <a:srgbClr val="0B0B0B"/>
                 </a:solidFill>
-                <a:latin typeface="Arial"/>
+                <a:latin typeface="Liberation Sans"/>
               </a:rPr>
               <a:t>Una estrategia distinta para cada perfil, con indicador medible</a:t>
             </a:r>
@@ -5169,7 +5169,7 @@
                           <a:solidFill>
                             <a:srgbClr val="0B0B0B"/>
                           </a:solidFill>
-                          <a:latin typeface="Arial"/>
+                          <a:latin typeface="Liberation Sans"/>
                         </a:rPr>
                         <a:t>Perfil</a:t>
                       </a:r>
@@ -5191,7 +5191,7 @@
                           <a:solidFill>
                             <a:srgbClr val="0B0B0B"/>
                           </a:solidFill>
-                          <a:latin typeface="Arial"/>
+                          <a:latin typeface="Liberation Sans"/>
                         </a:rPr>
                         <a:t>Prioridad</a:t>
                       </a:r>
@@ -5213,7 +5213,7 @@
                           <a:solidFill>
                             <a:srgbClr val="0B0B0B"/>
                           </a:solidFill>
-                          <a:latin typeface="Arial"/>
+                          <a:latin typeface="Liberation Sans"/>
                         </a:rPr>
                         <a:t>Objetivo</a:t>
                       </a:r>
@@ -5235,7 +5235,7 @@
                           <a:solidFill>
                             <a:srgbClr val="0B0B0B"/>
                           </a:solidFill>
-                          <a:latin typeface="Arial"/>
+                          <a:latin typeface="Liberation Sans"/>
                         </a:rPr>
                         <a:t>Indicador</a:t>
                       </a:r>
@@ -5259,7 +5259,7 @@
                           <a:solidFill>
                             <a:srgbClr val="0B0B0B"/>
                           </a:solidFill>
-                          <a:latin typeface="Arial"/>
+                          <a:latin typeface="Liberation Sans"/>
                         </a:rPr>
                         <a:t>1. Jóvenes urbanos de coyuntura</a:t>
                       </a:r>
@@ -5281,7 +5281,7 @@
                           <a:solidFill>
                             <a:srgbClr val="0B0B0B"/>
                           </a:solidFill>
-                          <a:latin typeface="Arial"/>
+                          <a:latin typeface="Liberation Sans"/>
                         </a:rPr>
                         <a:t>Alta</a:t>
                       </a:r>
@@ -5303,7 +5303,7 @@
                           <a:solidFill>
                             <a:srgbClr val="0B0B0B"/>
                           </a:solidFill>
-                          <a:latin typeface="Arial"/>
+                          <a:latin typeface="Liberation Sans"/>
                         </a:rPr>
                         <a:t>Reducir la brecha entre elecciones presidenciales e intermedias.</a:t>
                       </a:r>
@@ -5325,7 +5325,7 @@
                           <a:solidFill>
                             <a:srgbClr val="0B0B0B"/>
                           </a:solidFill>
-                          <a:latin typeface="Arial"/>
+                          <a:latin typeface="Liberation Sans"/>
                         </a:rPr>
                         <a:t>Participación de las personas de 20 a 34 años en la elección intermedia de 2027 frente a 2021.</a:t>
                       </a:r>
@@ -5349,7 +5349,7 @@
                           <a:solidFill>
                             <a:srgbClr val="0B0B0B"/>
                           </a:solidFill>
-                          <a:latin typeface="Arial"/>
+                          <a:latin typeface="Liberation Sans"/>
                         </a:rPr>
                         <a:t>2. Jóvenes del campo en retirada</a:t>
                       </a:r>
@@ -5371,7 +5371,7 @@
                           <a:solidFill>
                             <a:srgbClr val="0B0B0B"/>
                           </a:solidFill>
-                          <a:latin typeface="Arial"/>
+                          <a:latin typeface="Liberation Sans"/>
                         </a:rPr>
                         <a:t>Alta</a:t>
                       </a:r>
@@ -5393,7 +5393,7 @@
                           <a:solidFill>
                             <a:srgbClr val="0B0B0B"/>
                           </a:solidFill>
-                          <a:latin typeface="Arial"/>
+                          <a:latin typeface="Liberation Sans"/>
                         </a:rPr>
                         <a:t>Entender y frenar la caída sostenida de participación.</a:t>
                       </a:r>
@@ -5415,7 +5415,7 @@
                           <a:solidFill>
                             <a:srgbClr val="0B0B0B"/>
                           </a:solidFill>
-                          <a:latin typeface="Arial"/>
+                          <a:latin typeface="Liberation Sans"/>
                         </a:rPr>
                         <a:t>Participación del perfil en 2027 y 2030 frente a 2024.</a:t>
                       </a:r>
@@ -5439,7 +5439,7 @@
                           <a:solidFill>
                             <a:srgbClr val="0B0B0B"/>
                           </a:solidFill>
-                          <a:latin typeface="Arial"/>
+                          <a:latin typeface="Liberation Sans"/>
                         </a:rPr>
                         <a:t>3. Adultez urbana constante</a:t>
                       </a:r>
@@ -5461,7 +5461,7 @@
                           <a:solidFill>
                             <a:srgbClr val="0B0B0B"/>
                           </a:solidFill>
-                          <a:latin typeface="Arial"/>
+                          <a:latin typeface="Liberation Sans"/>
                         </a:rPr>
                         <a:t>Media</a:t>
                       </a:r>
@@ -5483,7 +5483,7 @@
                           <a:solidFill>
                             <a:srgbClr val="0B0B0B"/>
                           </a:solidFill>
-                          <a:latin typeface="Arial"/>
+                          <a:latin typeface="Liberation Sans"/>
                         </a:rPr>
                         <a:t>Conservar la participación y convertirla en un recurso cívico.</a:t>
                       </a:r>
@@ -5505,7 +5505,7 @@
                           <a:solidFill>
                             <a:srgbClr val="0B0B0B"/>
                           </a:solidFill>
-                          <a:latin typeface="Arial"/>
+                          <a:latin typeface="Liberation Sans"/>
                         </a:rPr>
                         <a:t>Aceptación de la invitación como funcionaria o funcionario de casilla.</a:t>
                       </a:r>
@@ -5529,7 +5529,7 @@
                           <a:solidFill>
                             <a:srgbClr val="0B0B0B"/>
                           </a:solidFill>
-                          <a:latin typeface="Arial"/>
+                          <a:latin typeface="Liberation Sans"/>
                         </a:rPr>
                         <a:t>4. Mayores en ascenso</a:t>
                       </a:r>
@@ -5551,7 +5551,7 @@
                           <a:solidFill>
                             <a:srgbClr val="0B0B0B"/>
                           </a:solidFill>
-                          <a:latin typeface="Arial"/>
+                          <a:latin typeface="Liberation Sans"/>
                         </a:rPr>
                         <a:t>Media</a:t>
                       </a:r>
@@ -5573,7 +5573,7 @@
                           <a:solidFill>
                             <a:srgbClr val="0B0B0B"/>
                           </a:solidFill>
-                          <a:latin typeface="Arial"/>
+                          <a:latin typeface="Liberation Sans"/>
                         </a:rPr>
                         <a:t>Sostener el aumento de participación facilitando el acceso.</a:t>
                       </a:r>
@@ -5595,7 +5595,7 @@
                           <a:solidFill>
                             <a:srgbClr val="0B0B0B"/>
                           </a:solidFill>
-                          <a:latin typeface="Arial"/>
+                          <a:latin typeface="Liberation Sans"/>
                         </a:rPr>
                         <a:t>Participación del perfil en 2027 frente a 2021 y casillas con acceso revisado.</a:t>
                       </a:r>
@@ -5619,7 +5619,7 @@
                           <a:solidFill>
                             <a:srgbClr val="0B0B0B"/>
                           </a:solidFill>
-                          <a:latin typeface="Arial"/>
+                          <a:latin typeface="Liberation Sans"/>
                         </a:rPr>
                         <a:t>5. Adultez rural de alta participación</a:t>
                       </a:r>
@@ -5641,7 +5641,7 @@
                           <a:solidFill>
                             <a:srgbClr val="0B0B0B"/>
                           </a:solidFill>
-                          <a:latin typeface="Arial"/>
+                          <a:latin typeface="Liberation Sans"/>
                         </a:rPr>
                         <a:t>Mantener</a:t>
                       </a:r>
@@ -5663,7 +5663,7 @@
                           <a:solidFill>
                             <a:srgbClr val="0B0B0B"/>
                           </a:solidFill>
-                          <a:latin typeface="Arial"/>
+                          <a:latin typeface="Liberation Sans"/>
                         </a:rPr>
                         <a:t>Mantener la participación más alta y apoyarse en sus redes comunitarias.</a:t>
                       </a:r>
@@ -5685,7 +5685,7 @@
                           <a:solidFill>
                             <a:srgbClr val="0B0B0B"/>
                           </a:solidFill>
-                          <a:latin typeface="Arial"/>
+                          <a:latin typeface="Liberation Sans"/>
                         </a:rPr>
                         <a:t>Participación del perfil en 2027 frente a 2021.</a:t>
                       </a:r>

</xml_diff>

<commit_message>
Spec 004: variantes de segmentación, arquetipos y nombres en lenguaje ciudadano
- Variantes candidatas (k-means con volatilidad, PCA de la participación
  relativa, Gower con k-medoides, K-Prototypes, consenso y mezcla
  gaussiana) con métricas en un espacio común y compuerta D4. Ninguna
  reemplaza a la principal: km4 es la corrida volatilidad de la 002.
- Análisis de arquetipos ponderado como lectura complementaria: k=4 por
  el codo y anclas solo en celdas con LN media >= 5,000 (D8 y D11,
  declaradas después de ver los datos). Mezcla por celda, perfil y
  sección, párrafo en la sección 3.6 del PDF.
- Nombres de perfiles y polos en lenguaje ciudadano e incluyente;
  fichas, PDF, presentación y figuras regenerados.
- Enmienda del art. 1: seaborn, kmodes y SciPy directo.

Co-Authored-By: Claude Opus 5.5 <noreply@anthropic.com>
</commit_message>
<xml_diff>
--- a/entrega/presentacion_ejecutiva.pptx
+++ b/entrega/presentacion_ejecutiva.pptx
@@ -4603,7 +4603,7 @@
                 </a:solidFill>
                 <a:latin typeface="Liberation Sans"/>
               </a:rPr>
-              <a:t>1. Urbanos de participación intermitente</a:t>
+              <a:t>1. Población urbana que vota en presidenciales</a:t>
             </a:r>
           </a:p>
           <a:p>
@@ -4690,7 +4690,7 @@
                 </a:solidFill>
                 <a:latin typeface="Liberation Sans"/>
               </a:rPr>
-              <a:t>2. Jóvenes del campo en retirada</a:t>
+              <a:t>2. Juventud rural que vota cada vez menos</a:t>
             </a:r>
           </a:p>
           <a:p>
@@ -4842,7 +4842,7 @@
                 </a:solidFill>
                 <a:latin typeface="Liberation Sans"/>
               </a:rPr>
-              <a:t>3. Adultez urbana constante</a:t>
+              <a:t>3. Personas adultas de ciudad con voto constante</a:t>
             </a:r>
           </a:p>
           <a:p>
@@ -4929,7 +4929,7 @@
                 </a:solidFill>
                 <a:latin typeface="Liberation Sans"/>
               </a:rPr>
-              <a:t>4. Mayores en ascenso</a:t>
+              <a:t>4. Personas mayores que votan cada vez más</a:t>
             </a:r>
           </a:p>
           <a:p>
@@ -5016,7 +5016,7 @@
                 </a:solidFill>
                 <a:latin typeface="Liberation Sans"/>
               </a:rPr>
-              <a:t>5. Adultez de alta participación</a:t>
+              <a:t>5. Personas adultas y mayores que votan en toda elección</a:t>
             </a:r>
           </a:p>
           <a:p>
@@ -5261,7 +5261,7 @@
                           </a:solidFill>
                           <a:latin typeface="Liberation Sans"/>
                         </a:rPr>
-                        <a:t>1. Urbanos de participación intermitente</a:t>
+                        <a:t>1. Población urbana que vota en presidenciales</a:t>
                       </a:r>
                     </a:p>
                   </a:txBody>
@@ -5351,7 +5351,7 @@
                           </a:solidFill>
                           <a:latin typeface="Liberation Sans"/>
                         </a:rPr>
-                        <a:t>2. Jóvenes del campo en retirada</a:t>
+                        <a:t>2. Juventud rural que vota cada vez menos</a:t>
                       </a:r>
                     </a:p>
                   </a:txBody>
@@ -5441,7 +5441,7 @@
                           </a:solidFill>
                           <a:latin typeface="Liberation Sans"/>
                         </a:rPr>
-                        <a:t>3. Adultez urbana constante</a:t>
+                        <a:t>3. Personas adultas de ciudad con voto constante</a:t>
                       </a:r>
                     </a:p>
                   </a:txBody>
@@ -5531,7 +5531,7 @@
                           </a:solidFill>
                           <a:latin typeface="Liberation Sans"/>
                         </a:rPr>
-                        <a:t>4. Mayores en ascenso</a:t>
+                        <a:t>4. Personas mayores que votan cada vez más</a:t>
                       </a:r>
                     </a:p>
                   </a:txBody>
@@ -5621,7 +5621,7 @@
                           </a:solidFill>
                           <a:latin typeface="Liberation Sans"/>
                         </a:rPr>
-                        <a:t>5. Adultez de alta participación</a:t>
+                        <a:t>5. Personas adultas y mayores que votan en toda elección</a:t>
                       </a:r>
                     </a:p>
                   </a:txBody>

</xml_diff>